<commit_message>
Complete fixed Unmask audit and nine-slide meeting report; explicitly retain unresolved Defense2 mechanism
</commit_message>
<xml_diff>
--- a/presentation/research_report.pptx
+++ b/presentation/research_report.pptx
@@ -510,7 +510,12 @@
           <a:lstStyle/>
           <a:p>
             <a:r>
-              <a:t>LaTeX-generated slide. Edit presentation/main.tex and regenerate.</a:t>
+              <a:t>汇报三件事：两套后处理防御及攻击评估。明确已完成、失败和仍未完成的研究，不宣称全部解决。</a:t>
+            </a:r>
+          </a:p>
+          <a:p>
+            <a:r>
+              <a:t>LaTeX源稿：presentation/main.tex；数值由update_tables.py生成。</a:t>
             </a:r>
           </a:p>
         </p:txBody>
@@ -580,7 +585,12 @@
           <a:lstStyle/>
           <a:p>
             <a:r>
-              <a:t>LaTeX-generated slide. Edit presentation/main.tex and regenerate.</a:t>
+              <a:t>原专家冻结。仅发布变换可优化，构造不读未来伙伴或测试反馈；目标任务和伙伴任务必须分开报告。</a:t>
+            </a:r>
+          </a:p>
+          <a:p>
+            <a:r>
+              <a:t>LaTeX源稿：presentation/main.tex；数值由update_tables.py生成。</a:t>
             </a:r>
           </a:p>
         </p:txBody>
@@ -650,7 +660,12 @@
           <a:lstStyle/>
           <a:p>
             <a:r>
-              <a:t>LaTeX-generated slide. Edit presentation/main.tex and regenerate.</a:t>
+              <a:t>偏置核空间保持是理想算术恒等式；原AGA没有处理关键最终偏置。高独立准确率和低融合准确率都不构成普遍安全证明。</a:t>
+            </a:r>
+          </a:p>
+          <a:p>
+            <a:r>
+              <a:t>LaTeX源稿：presentation/main.tex；数值由update_tables.py生成。</a:t>
             </a:r>
           </a:p>
         </p:txBody>
@@ -720,7 +735,12 @@
           <a:lstStyle/>
           <a:p>
             <a:r>
-              <a:t>LaTeX-generated slide. Edit presentation/main.tex and regenerate.</a:t>
+              <a:t>距离最大化目标确实存在。旧O/B上游仅开放任务SVD坐标，B输入范围较大而输出受限。有限探针不等于功能零空间。原优化为有限任务约束下的可行更新与非线性校正，不是未知伙伴安全博弈。</a:t>
+            </a:r>
+          </a:p>
+          <a:p>
+            <a:r>
+              <a:t>LaTeX源稿：presentation/main.tex；数值由update_tables.py生成。</a:t>
             </a:r>
           </a:p>
         </p:txBody>
@@ -790,7 +810,12 @@
           <a:lstStyle/>
           <a:p>
             <a:r>
-              <a:t>LaTeX-generated slide. Edit presentation/main.tex and regenerate.</a:t>
+              <a:t>上下两表是不同协议：两专家TA0.5与八专家TA0.2。后者只评三任务，不能报八任务平均。O/B和A/B都只作预算违规的效果参考。</a:t>
+            </a:r>
+          </a:p>
+          <a:p>
+            <a:r>
+              <a:t>LaTeX源稿：presentation/main.tex；数值由update_tables.py生成。</a:t>
             </a:r>
           </a:p>
         </p:txBody>
@@ -860,7 +885,12 @@
           <a:lstStyle/>
           <a:p>
             <a:r>
-              <a:t>LaTeX-generated slide. Edit presentation/main.tex and regenerate.</a:t>
+              <a:t>任务误差是教师对各竞争类别的相对间隔变化。低间隔会放大非零误差；独立准确率未变仍可能越界。旧反例及新任务外固定点均不用于修补。</a:t>
+            </a:r>
+          </a:p>
+          <a:p>
+            <a:r>
+              <a:t>LaTeX源稿：presentation/main.tex；数值由update_tables.py生成。</a:t>
             </a:r>
           </a:p>
         </p:txBody>
@@ -930,7 +960,12 @@
           <a:lstStyle/>
           <a:p>
             <a:r>
-              <a:t>LaTeX-generated slide. Edit presentation/main.tex and regenerate.</a:t>
+              <a:t>Unmask整份参数减法0.3已完整评价，无保护控制也严重退化，不能据低分声称防御成功。区分完整官方代码、官方内核的native适配、论文公式实现与未取得代码。ProDistill需要校准图和任务归属，逐元素系数可有很高维度；它属于数据辅助融合。</a:t>
+            </a:r>
+          </a:p>
+          <a:p>
+            <a:r>
+              <a:t>LaTeX源稿：presentation/main.tex；数值由update_tables.py生成。</a:t>
             </a:r>
           </a:p>
         </p:txBody>
@@ -1000,7 +1035,12 @@
           <a:lstStyle/>
           <a:p>
             <a:r>
-              <a:t>LaTeX-generated slide. Edit presentation/main.tex and regenerate.</a:t>
+              <a:t>NUFILT跳过编辑位置，产生与无保护相同的合并模型，不等于恢复了原偏置。偏置清理的不同精度协议分列，旧数值失败保留。</a:t>
+            </a:r>
+          </a:p>
+          <a:p>
+            <a:r>
+              <a:t>LaTeX源稿：presentation/main.tex；数值由update_tables.py生成。</a:t>
             </a:r>
           </a:p>
         </p:txBody>
@@ -1070,7 +1110,12 @@
           <a:lstStyle/>
           <a:p>
             <a:r>
-              <a:t>LaTeX-generated slide. Edit presentation/main.tex and regenerate.</a:t>
+              <a:t>Defense2新的合规有效方法仍是最大缺口。下一步先给完整原生结构的可实现条件和可证伪假设；不要再机械放大噪声或扫描秩、种子和模块。</a:t>
+            </a:r>
+          </a:p>
+          <a:p>
+            <a:r>
+              <a:t>LaTeX源稿：presentation/main.tex；数值由update_tables.py生成。</a:t>
             </a:r>
           </a:p>
         </p:txBody>
@@ -4078,7 +4123,7 @@
       <p:grpSpPr/>
       <p:pic>
         <p:nvPicPr>
-          <p:cNvPr id="2" name="Picture 1" descr="page-01.png"/>
+          <p:cNvPr id="2" name="Picture 1" descr="page-1.png"/>
           <p:cNvPicPr>
             <a:picLocks noChangeAspect="1"/>
           </p:cNvPicPr>
@@ -4120,7 +4165,7 @@
       <p:grpSpPr/>
       <p:pic>
         <p:nvPicPr>
-          <p:cNvPr id="2" name="Picture 1" descr="page-02.png"/>
+          <p:cNvPr id="2" name="Picture 1" descr="page-2.png"/>
           <p:cNvPicPr>
             <a:picLocks noChangeAspect="1"/>
           </p:cNvPicPr>
@@ -4162,7 +4207,7 @@
       <p:grpSpPr/>
       <p:pic>
         <p:nvPicPr>
-          <p:cNvPr id="2" name="Picture 1" descr="page-03.png"/>
+          <p:cNvPr id="2" name="Picture 1" descr="page-3.png"/>
           <p:cNvPicPr>
             <a:picLocks noChangeAspect="1"/>
           </p:cNvPicPr>
@@ -4204,7 +4249,7 @@
       <p:grpSpPr/>
       <p:pic>
         <p:nvPicPr>
-          <p:cNvPr id="2" name="Picture 1" descr="page-04.png"/>
+          <p:cNvPr id="2" name="Picture 1" descr="page-4.png"/>
           <p:cNvPicPr>
             <a:picLocks noChangeAspect="1"/>
           </p:cNvPicPr>
@@ -4246,7 +4291,7 @@
       <p:grpSpPr/>
       <p:pic>
         <p:nvPicPr>
-          <p:cNvPr id="2" name="Picture 1" descr="page-05.png"/>
+          <p:cNvPr id="2" name="Picture 1" descr="page-5.png"/>
           <p:cNvPicPr>
             <a:picLocks noChangeAspect="1"/>
           </p:cNvPicPr>
@@ -4288,7 +4333,7 @@
       <p:grpSpPr/>
       <p:pic>
         <p:nvPicPr>
-          <p:cNvPr id="2" name="Picture 1" descr="page-06.png"/>
+          <p:cNvPr id="2" name="Picture 1" descr="page-6.png"/>
           <p:cNvPicPr>
             <a:picLocks noChangeAspect="1"/>
           </p:cNvPicPr>
@@ -4330,7 +4375,7 @@
       <p:grpSpPr/>
       <p:pic>
         <p:nvPicPr>
-          <p:cNvPr id="2" name="Picture 1" descr="page-07.png"/>
+          <p:cNvPr id="2" name="Picture 1" descr="page-7.png"/>
           <p:cNvPicPr>
             <a:picLocks noChangeAspect="1"/>
           </p:cNvPicPr>
@@ -4372,7 +4417,7 @@
       <p:grpSpPr/>
       <p:pic>
         <p:nvPicPr>
-          <p:cNvPr id="2" name="Picture 1" descr="page-08.png"/>
+          <p:cNvPr id="2" name="Picture 1" descr="page-8.png"/>
           <p:cNvPicPr>
             <a:picLocks noChangeAspect="1"/>
           </p:cNvPicPr>
@@ -4414,7 +4459,7 @@
       <p:grpSpPr/>
       <p:pic>
         <p:nvPicPr>
-          <p:cNvPr id="2" name="Picture 1" descr="page-09.png"/>
+          <p:cNvPr id="2" name="Picture 1" descr="page-9.png"/>
           <p:cNvPicPr>
             <a:picLocks noChangeAspect="1"/>
           </p:cNvPicPr>

</xml_diff>

<commit_message>
Publish independently verified full PaRaMS and task-directed three-task results, fixed distance ablation, matching MD/TeX tables, and preregistered public recovery; mirrors local771ff283
</commit_message>
<xml_diff>
--- a/presentation/research_report.pptx
+++ b/presentation/research_report.pptx
@@ -810,7 +810,7 @@
           <a:lstStyle/>
           <a:p>
             <a:r>
-              <a:t>上下两表是不同协议：两专家TA0.5与八专家TA0.2。后者只评三任务，不能报八任务平均。O/B和A/B都只作预算违规的效果参考。</a:t>
+              <a:t>上下两表是不同协议：两专家TA0.5与八专家TA0.2。后者只评三任务。O/B和A/B都有预算反例。新增功能保持对照通过新确认和完整MNIST任务门控，但TA99.34、AGA-target99.26、both99.31，保护无效，已关闭，未据结果调参。</a:t>
             </a:r>
           </a:p>
           <a:p>
@@ -885,7 +885,7 @@
           <a:lstStyle/>
           <a:p>
             <a:r>
-              <a:t>任务误差是教师对各竞争类别的相对间隔变化。低间隔会放大非零误差；独立准确率未变仍可能越界。旧反例及新任务外固定点均不用于修补。</a:t>
+              <a:t>任务误差是教师对各竞争类别的相对间隔变化。O/B、A/B是512张训练审计，新对照是10000张历史测试，样本范围不同。新对照参数距离0.4999995、完整任务漂移0.0001205，保持通过；真实目标保护失败。有限SVD补空间幅度大不代表分类损害。</a:t>
             </a:r>
           </a:p>
           <a:p>

</xml_diff>